<commit_message>
fix: reconcile final deliverables and presentation deck to ground-truth figures
- Synchronize PowerPoint decks (14 slides) to verified deposit liabilities (₹131.09 Cr) and churn balance at risk (₹67.33 Cr / 51.37%)
- Update segment at-risk distribution (Wealth: ₹39.73 Cr, Privileged: ₹19.67 Cr, Mass Retail: ₹7.94 Cr)
- Reconcile frontline archetypes (A-F) and top 5 branch hubs (BR004, BR001, BR023, BR014, BR012)
- Update auditor.py and checklist_builder.py to reflect exact ground truth and regenerate audit workbooks
- Synchronize narrative figures across docs (06, 07, 09, 10, FINAL_README, powerbi/README)
</commit_message>
<xml_diff>
--- a/output/Apex_Retail_Bank_Executive_Presentation.pptx
+++ b/output/Apex_Retail_Bank_Executive_Presentation.pptx
@@ -530,12 +530,12 @@
           </a:p>
           <a:p>
             <a:r>
-              <a:t>Apex Retail Bank manages 10,200 core retail customers and over ₹1,365 Crores in deposits. However, behind stable topline numbers, the bank faces an insidious threat: silent churn—customers quietly draining funds without closing accounts.</a:t>
-            </a:r>
-          </a:p>
-          <a:p>
-            <a:r>
-              <a:t>Our framework builds a unified Customer 360 architecture, resolves critical data quality vulnerabilities, isolates ₹337.89 Crores of at-risk deposits, and delivers an explainable, archetype-driven intervention engine.</a:t>
+              <a:t>Apex Retail Bank manages 10,200 core retail customers and ₹131.09 Crores in total deposit balances across 14,000 accounts. However, behind stable headline customer counts, the bank faces an insidious threat: silent churn—customers quietly draining funds without closing accounts.</a:t>
+            </a:r>
+          </a:p>
+          <a:p>
+            <a:r>
+              <a:t>Our framework builds a unified Customer 360 architecture, resolves critical data quality vulnerabilities, isolates ₹67.33 Crores of at-risk deposits (51.4% of total balances), and delivers an explainable, archetype-driven intervention engine.</a:t>
             </a:r>
           </a:p>
         </p:txBody>
@@ -615,17 +615,17 @@
           </a:p>
           <a:p>
             <a:r>
-              <a:t>We clustered the at-risk population into 6 mutually exclusive operational archetypes:</a:t>
-            </a:r>
-          </a:p>
-          <a:p>
-            <a:r>
-              <a:t>Notice Archetype B: 512 customers had massive outflows, but no service complaints and healthy digital logins. Calling them with desperate retention discounts annoys them. The rule engine prescribes: 'Monitor for 30 days; do not harass.'</a:t>
-            </a:r>
-          </a:p>
-          <a:p>
-            <a:r>
-              <a:t>Contrast that with Archetype A: high balances combined with complaints and digital drop-off. These 198 customers represent ₹112 Crores. They get senior RM outreach within 48 hours.</a:t>
+              <a:t>We clustered the customer population into 6 mutually exclusive operational archetypes:</a:t>
+            </a:r>
+          </a:p>
+          <a:p>
+            <a:r>
+              <a:t>Notice Archetype B: 599 customers had massive outflows, but no service complaints and healthy digital logins. Calling them with desperate retention discounts annoys them. The rule engine prescribes: 'Monitor for 30 days; do not harass.'</a:t>
+            </a:r>
+          </a:p>
+          <a:p>
+            <a:r>
+              <a:t>Contrast that with Archetype A: high balances combined with complaints and digital drop-off. These 165 customers represent ₹23.62 Crores in immediate flight risk. They get senior RM outreach within 48 hours.</a:t>
             </a:r>
           </a:p>
         </p:txBody>
@@ -795,27 +795,27 @@
           </a:p>
           <a:p>
             <a:r>
-              <a:t>Our analysis demonstrates that silent churn is not evenly dispersed across the bank's 30 branches.</a:t>
-            </a:r>
-          </a:p>
-          <a:p>
-            <a:r>
-              <a:t>Just 5 branches account for over ₹129 Crores—nearly 40% of the entire at-risk deposit base.</a:t>
-            </a:r>
-          </a:p>
-          <a:p>
-            <a:r>
-              <a:t>Branch BR-104 alone has ₹34.8 Crores at risk due to commercial client NetBanking outages.</a:t>
-            </a:r>
-          </a:p>
-          <a:p>
-            <a:r>
-              <a:t>Meanwhile, BR-112's risk is service-driven: resolution TAT is double the bank average.</a:t>
-            </a:r>
-          </a:p>
-          <a:p>
-            <a:r>
-              <a:t>This allows leadership to deploy targeted regional resources where capital flight is concentrated.</a:t>
+              <a:t>Our analysis demonstrates that silent churn is concentrated across key urban and commercial hubs among the bank's 50 branches.</a:t>
+            </a:r>
+          </a:p>
+          <a:p>
+            <a:r>
+              <a:t>Just 5 branches (BR004, BR001, BR023, BR014, and BR012) account for ₹14.39 Crores in at-risk deposits and over 1,500 customer complaints.</a:t>
+            </a:r>
+          </a:p>
+          <a:p>
+            <a:r>
+              <a:t>Branch BR004 alone has ₹3.26 Crores at risk with a 69.5% risk rate, driven by high-balance Wealth client outflows.</a:t>
+            </a:r>
+          </a:p>
+          <a:p>
+            <a:r>
+              <a:t>Meanwhile, BR001 combines ₹3.17 Crores at risk with our lowest customer CSAT (3.58) and active NPAs.</a:t>
+            </a:r>
+          </a:p>
+          <a:p>
+            <a:r>
+              <a:t>This allows leadership to deploy targeted regional resources exactly where capital flight is concentrated.</a:t>
             </a:r>
           </a:p>
         </p:txBody>
@@ -900,7 +900,7 @@
           </a:p>
           <a:p>
             <a:r>
-              <a:t>- Head of Wealth Banking owns P1 outreach for the top 198 accounts.</a:t>
+              <a:t>- Head of Wealth Banking owns P1 outreach for the top 165 Archetype A accounts.</a:t>
             </a:r>
           </a:p>
           <a:p>
@@ -995,12 +995,12 @@
           </a:p>
           <a:p>
             <a:r>
-              <a:t>In the first 30 days, we stop the bleeding. We contact the top 198 Archetype A customers to protect ₹112 Crores in immediate flight risk, and clean up the 480 duplicate PAN records.</a:t>
-            </a:r>
-          </a:p>
-          <a:p>
-            <a:r>
-              <a:t>In days 31 to 60, we tackle operational root causes: fixing the service bottleneck in branch BR-112 and reviving digital engagement.</a:t>
+              <a:t>In the first 30 days, we stop the bleeding. We contact the top 165 Archetype A customers to protect ₹23.62 Crores in immediate flight risk, and clean up the 480 duplicate PAN records.</a:t>
+            </a:r>
+          </a:p>
+          <a:p>
+            <a:r>
+              <a:t>In days 31 to 60, we tackle operational root causes: fixing service bottlenecks in branches BR004 and BR001 and reviving digital engagement.</a:t>
             </a:r>
           </a:p>
           <a:p>
@@ -1100,12 +1100,12 @@
           </a:p>
           <a:p>
             <a:r>
-              <a:t>2. WHY DOES IT MATTER? [DERIVED]: These at-risk accounts hold ₹337.89 Crores in deposits—that is one-quarter of the bank's total retail balance sheet.</a:t>
-            </a:r>
-          </a:p>
-          <a:p>
-            <a:r>
-              <a:t>3. WHO IS EXPOSED? [DERIVED]: While Mass Retail has more heads, the Wealth segment represents almost half of the at-risk deposit money. Furthermore, risk is regionally concentrated.</a:t>
+              <a:t>2. WHY DOES IT MATTER? [DERIVED]: These at-risk accounts hold ₹67.33 Crores in deposits—that is over half (51.4%) of the bank's total retail deposit base of ₹131.09 Crores.</a:t>
+            </a:r>
+          </a:p>
+          <a:p>
+            <a:r>
+              <a:t>3. WHO IS EXPOSED? [DERIVED]: While Mass Retail has more customer accounts, the Wealth segment represents nearly 60% of all at-risk deposits (₹39.73 Cr). Furthermore, risk is regionally concentrated across key urban branches.</a:t>
             </a:r>
           </a:p>
           <a:p>
@@ -1205,7 +1205,7 @@
           </a:p>
           <a:p>
             <a:r>
-              <a:t>3. JOIN INFLATION PREVENTION: Merging transactions and accounts naively causes severe fan-out that inflates customer balances. We pre-aggregated transaction metrics per account and customer before joining to Customer_Master, proving 100% financial balance reconciliation to ₹1,365.42 Crores.</a:t>
+              <a:t>3. JOIN INFLATION PREVENTION: Merging transactions and accounts naively causes severe fan-out that inflates customer balances. We pre-aggregated transaction metrics per account and customer before joining to Customer_Master, proving 100% financial balance reconciliation to ₹131.09 Crores.</a:t>
             </a:r>
           </a:p>
         </p:txBody>
@@ -1685,7 +1685,7 @@
           </a:p>
           <a:p>
             <a:r>
-              <a:t>Our total portfolio holds ₹1,365.42 Crores. Exactly ₹337.89 Crores is held by 2,402 customers currently drifting toward silent attrition.</a:t>
+              <a:t>Our total portfolio holds ₹131.09 Crores across 14,000 accounts. Exactly ₹67.33 Crores (51.4%) is held by 2,402 customers currently drifting toward silent attrition.</a:t>
             </a:r>
           </a:p>
           <a:p>
@@ -1695,12 +1695,12 @@
           </a:p>
           <a:p>
             <a:r>
-              <a:t>Wealth customers represent only 10% of our customer count, but they represent 48% of the money at risk—over ₹162 Crores!</a:t>
-            </a:r>
-          </a:p>
-          <a:p>
-            <a:r>
-              <a:t>Privileged customers account for another ₹108 Crores.</a:t>
+              <a:t>Wealth customers represent only 8.5% of our customer count (865 customers), but they hold ₹65.13 Crores in deposits and represent nearly 60% of all balance at risk—over ₹39.73 Crores! 61% of all Wealth deposits are under severe flight risk.</a:t>
+            </a:r>
+          </a:p>
+          <a:p>
+            <a:r>
+              <a:t>Privileged customers account for another ₹19.67 Crores.</a:t>
             </a:r>
           </a:p>
           <a:p>
@@ -5088,7 +5088,7 @@
               </a:defRPr>
             </a:pPr>
             <a:r>
-              <a:t>• Archetype A — High Value + Multi-Signal Risk (198 Customers | ₹112.4 Cr): High deposit balance + simultaneous outflow, digital decay, and complaints. ➔ PROTOCOL: Priority Senior RM outreach within 48h; personalized wealth retention offer.</a:t>
+              <a:t>• Archetype A — High Value + Multi-Signal Risk (165 Customers | ₹23.62 Cr): High deposit balance + simultaneous outflow, digital decay, and complaints. ➔ PROTOCOL: Priority Senior RM outreach within 48h; personalized wealth retention offer.</a:t>
             </a:r>
           </a:p>
           <a:p>
@@ -5101,7 +5101,7 @@
               </a:defRPr>
             </a:pPr>
             <a:r>
-              <a:t>• Archetype B — High Outflow + Weak Supporting Evidence (512 Customers | ₹68.2 Cr): Large single outflow without app decline or complaints (e.g., tax payment or real estate purchase). ➔ PROTOCOL: 30-day monitoring; DO NOT harass customer with churn retention calls.</a:t>
+              <a:t>• Archetype B — High Outflow + Weak Supporting Evidence (599 Customers | ₹7.90 Cr): Large single outflow without app decline or complaints (e.g., tax payment or real estate purchase). ➔ PROTOCOL: 30-day monitoring; DO NOT harass customer with churn retention calls.</a:t>
             </a:r>
           </a:p>
           <a:p>
@@ -5114,7 +5114,7 @@
               </a:defRPr>
             </a:pPr>
             <a:r>
-              <a:t>• Archetype C — Digital Decline + Service Friction (945 Customers | ₹74.6 Cr): Frustrated digital users with low CSAT and declining logins. ➔ PROTOCOL: Digital service recovery call, fee reversal where applicable, proactive app re-onboarding.</a:t>
+              <a:t>• Archetype C — Digital Decline + Service Friction (2,779 Customers | ₹27.27 Cr): Frustrated digital users with low CSAT and declining logins. ➔ PROTOCOL: Digital service recovery call, fee reversal where applicable, proactive app re-onboarding.</a:t>
             </a:r>
           </a:p>
           <a:p>
@@ -5127,7 +5127,7 @@
               </a:defRPr>
             </a:pPr>
             <a:r>
-              <a:t>• Archetype D — Credit Stress Driven Risk (314 Customers | ₹28.5 Cr): Elevated loan DPD (30–90 days) impacting broader banking relationship. ➔ PROTOCOL: Branch credit counseling, debt restructuring review, proactive restructuring counseling.</a:t>
+              <a:t>• Archetype D — Credit Stress Driven Risk (1,193 Customers | ₹9.96 Cr): Elevated loan DPD (30–90 days) impacting broader banking relationship. ➔ PROTOCOL: Branch credit counseling, debt restructuring review, proactive restructuring counseling.</a:t>
             </a:r>
           </a:p>
           <a:p>
@@ -5140,7 +5140,7 @@
               </a:defRPr>
             </a:pPr>
             <a:r>
-              <a:t>• Archetype E — Data Confidence Limited Risk (433 Customers | ₹14.1 Cr): Incomplete KYC or missing profile data rendering risk score noisy. ➔ PROTOCOL: Immediate KYC remediation outreach before taking risk or marketing actions.</a:t>
+              <a:t>• Archetype E — Data Confidence Limited Risk (0 Customers with unresolvable data; 480 duplicate PAN &amp; 306 KYC records prioritized for remediation). ➔ PROTOCOL: In-app video-KYC link &amp; document collection before cross-selling.</a:t>
             </a:r>
           </a:p>
           <a:p>
@@ -5153,7 +5153,7 @@
               </a:defRPr>
             </a:pPr>
             <a:r>
-              <a:t>• Archetype F — Baseline / Stable (7,798 Customers | ₹1,067.6 Cr): Normal transaction cadence, moderate to low risk. ➔ PROTOCOL: Standard relationship management.</a:t>
+              <a:t>• Archetype F — Baseline / Stable (5,464 Customers | ₹62.33 Cr): Normal transaction cadence, moderate to low risk. ➔ PROTOCOL: Standard relationship management.</a:t>
             </a:r>
           </a:p>
         </p:txBody>
@@ -5786,7 +5786,7 @@
               </a:defRPr>
             </a:pPr>
             <a:r>
-              <a:t>Top 5 Branch Hotspots Account for 38% of At-Risk Deposits [DERIVED]</a:t>
+              <a:t>Top 5 Branch Hotspots Account for ₹14.39 Cr of At-Risk Deposits [DERIVED]</a:t>
             </a:r>
           </a:p>
           <a:p>
@@ -5799,7 +5799,7 @@
               </a:defRPr>
             </a:pPr>
             <a:r>
-              <a:t>• Branch BR-104 (Metropolitan Commercial Hub): 340 Customers | Total Deposits: ₹112.5 Cr | Balance at Risk: ₹34.8 Cr (30.9% risk rate). Driven by Wealth tier outflow and digital friction.</a:t>
+              <a:t>• Branch BR004 (Metropolitan Commercial Hub): 243 Customers | Total Deposits: ₹4.68 Cr | Balance at Risk: ₹3.26 Cr (69.5% risk rate) | 281 complaints, CSAT 3.75. Driven by Wealth tier outflow and digital friction.</a:t>
             </a:r>
           </a:p>
           <a:p>
@@ -5812,7 +5812,7 @@
               </a:defRPr>
             </a:pPr>
             <a:r>
-              <a:t>• Branch BR-112 (Suburban Retail Center): 410 Customers | Total Deposits: ₹94.2 Cr | Balance at Risk: ₹28.4 Cr (30.1% risk rate). Driven by high service TAT (average 16.2 days) and fee disputes.</a:t>
+              <a:t>• Branch BR001 (Urban Flagship Center): 285 Customers | Total Deposits: ₹4.36 Cr | Balance at Risk: ₹3.17 Cr (72.8% risk rate) | 350 complaints, CSAT 3.58, 2 NPAs. High service friction and dispute concentration.</a:t>
             </a:r>
           </a:p>
           <a:p>
@@ -5825,7 +5825,7 @@
               </a:defRPr>
             </a:pPr>
             <a:r>
-              <a:t>• Branch BR-108: 380 Customers | Total Deposits: ₹88.1 Cr | Balance at Risk: ₹24.6 Cr. High concentration of credit-stressed retail borrowers (NPA cluster).</a:t>
+              <a:t>• Branch BR023: 196 Customers | Total Deposits: ₹4.50 Cr | Balance at Risk: ₹2.82 Cr (62.6% risk rate) | 238 complaints. High average customer balance with declining mobile engagement.</a:t>
             </a:r>
           </a:p>
           <a:p>
@@ -5838,7 +5838,7 @@
               </a:defRPr>
             </a:pPr>
             <a:r>
-              <a:t>• Branch BR-121: 295 Customers | Total Deposits: ₹76.4 Cr | Balance at Risk: ₹22.1 Cr. Primary issue: pending KYC documentation causing account freeze frustrations.</a:t>
+              <a:t>• Branch BR014: 254 Customers | Total Deposits: ₹3.89 Cr | Balance at Risk: ₹2.60 Cr (66.7% risk rate) | 310 complaints. High debit outflow acceleration to competitor accounts.</a:t>
             </a:r>
           </a:p>
           <a:p>
@@ -5851,7 +5851,7 @@
               </a:defRPr>
             </a:pPr>
             <a:r>
-              <a:t>• Branch BR-115: 350 Customers | Total Deposits: ₹71.0 Cr | Balance at Risk: ₹19.8 Cr. High mobile banking complaint density.</a:t>
+              <a:t>• Branch BR012: 265 Customers | Total Deposits: ₹4.08 Cr | Balance at Risk: ₹2.54 Cr (62.2% risk rate) | 322 complaints, 2 NPAs. Dual service delays and credit delinquency.</a:t>
             </a:r>
           </a:p>
           <a:p>
@@ -5864,7 +5864,7 @@
               </a:defRPr>
             </a:pPr>
             <a:r>
-              <a:t>• Governance Mandate [RECOMMENDED]: Regional directors must not issue generic churn targets. Branch Managers at BR-104 and BR-112 require dedicated retention taskforces and dedicated service resolution liaisons.</a:t>
+              <a:t>• Governance Mandate [RECOMMENDED]: Regional directors must not issue generic churn targets. Top 5 branches account for 21.4% of all at-risk deposits and 1,501 complaints. Branch Managers at BR004 and BR001 require dedicated retention taskforces and senior RM liaisons.</a:t>
             </a:r>
           </a:p>
         </p:txBody>
@@ -6272,7 +6272,7 @@
               </a:defRPr>
             </a:pPr>
             <a:r>
-              <a:t>• Contact Top 198 Archetype A customers (protect ₹112.4 Cr).</a:t>
+              <a:t>• Contact Top 165 Archetype A customers (protect ₹23.62 Cr).</a:t>
             </a:r>
           </a:p>
           <a:p>
@@ -6391,7 +6391,7 @@
               </a:defRPr>
             </a:pPr>
             <a:r>
-              <a:t>• Dispatch service recovery squads to Top 5 risk branches (BR-104, BR-112, etc.).</a:t>
+              <a:t>• Dispatch service recovery squads to Top 5 risk branches (BR004, BR001, BR023, BR014, BR012).</a:t>
             </a:r>
           </a:p>
           <a:p>
@@ -6562,7 +6562,7 @@
               </a:defRPr>
             </a:pPr>
             <a:r>
-              <a:t>• Measure net deposit retention: Target ₹150+ Cr in preserved retail deposits.</a:t>
+              <a:t>• Measure net deposit retention: Target ₹30+ Cr in preserved retail deposits.</a:t>
             </a:r>
           </a:p>
         </p:txBody>
@@ -6845,7 +6845,7 @@
               </a:defRPr>
             </a:pPr>
             <a:r>
-              <a:t>₹337.89 Crores in retail deposits (24.7% of total portfolio) are directly exposed to flight risk, concentrated heavily in high-margin Wealth &amp; Privileged tiers.</a:t>
+              <a:t>₹67.33 Crores in retail deposits (51.4% of total portfolio) are directly exposed to flight risk, concentrated heavily in high-margin Wealth &amp; Privileged tiers.</a:t>
             </a:r>
           </a:p>
         </p:txBody>
@@ -6950,7 +6950,7 @@
               </a:defRPr>
             </a:pPr>
             <a:r>
-              <a:t>Wealth segment faces 48% of total deposit flight exposure. 5 core branch hubs account for 38% of at-risk balances, exacerbated by customer service friction.</a:t>
+              <a:t>Wealth segment accounts for 59.0% of at-risk deposits (₹39.73 Cr) with a 61.0% segment balance risk rate. Top 5 branches hold ₹14.39 Cr at risk.</a:t>
             </a:r>
           </a:p>
         </p:txBody>
@@ -7418,7 +7418,7 @@
               </a:defRPr>
             </a:pPr>
             <a:r>
-              <a:t>• Financial Balance Reconciliation: Accounts total ₹1,365.42 Cr matches Customer 360 exactly (0.00% discrepancy).</a:t>
+              <a:t>• Financial Balance Reconciliation: Accounts total ₹131.09 Cr matches Customer 360 exactly (0.00% discrepancy).</a:t>
             </a:r>
           </a:p>
         </p:txBody>
@@ -9267,7 +9267,7 @@
               </a:defRPr>
             </a:pPr>
             <a:r>
-              <a:t>₹1,365.42 Cr</a:t>
+              <a:t>₹131.09 Cr</a:t>
             </a:r>
           </a:p>
           <a:p>
@@ -9371,7 +9371,7 @@
               </a:defRPr>
             </a:pPr>
             <a:r>
-              <a:t>₹337.89 Cr</a:t>
+              <a:t>₹67.33 Cr</a:t>
             </a:r>
           </a:p>
           <a:p>
@@ -9383,7 +9383,7 @@
               </a:defRPr>
             </a:pPr>
             <a:r>
-              <a:t>24.7% of Portfolio Liabilities</a:t>
+              <a:t>51.4% of Portfolio Liabilities</a:t>
             </a:r>
           </a:p>
         </p:txBody>
@@ -9475,7 +9475,7 @@
               </a:defRPr>
             </a:pPr>
             <a:r>
-              <a:t>₹162.24 Cr</a:t>
+              <a:t>₹39.73 Cr</a:t>
             </a:r>
           </a:p>
           <a:p>
@@ -9487,7 +9487,7 @@
               </a:defRPr>
             </a:pPr>
             <a:r>
-              <a:t>48.0% of Total Balance at Risk</a:t>
+              <a:t>59.0% of Total Balance at Risk</a:t>
             </a:r>
           </a:p>
         </p:txBody>
@@ -9578,7 +9578,7 @@
               </a:defRPr>
             </a:pPr>
             <a:r>
-              <a:t>• Wealth Tier: 1,020 Customers (10.0% of base) | Total Deposits: ₹520.10 Cr | High Risk: 284 Customers | Balance at Risk: ₹162.24 Cr (31.2% of segment). Severe capital concentration.</a:t>
+              <a:t>• Wealth Tier: 865 Customers (8.5% of base) | Total Deposits: ₹65.13 Cr | High Risk: 463 Customers (53.5%) | Balance at Risk: ₹39.73 Cr (61.0% of segment). Severe capital concentration.</a:t>
             </a:r>
           </a:p>
           <a:p>
@@ -9591,7 +9591,7 @@
               </a:defRPr>
             </a:pPr>
             <a:r>
-              <a:t>• Privileged Tier: 3,060 Customers (30.0% of base) | Total Deposits: ₹465.80 Cr | High Risk: 735 Customers | Balance at Risk: ₹108.50 Cr (23.3% of segment). High digital banking sensitivity.</a:t>
+              <a:t>• Privileged Tier: 2,099 Customers (20.6% of base) | Total Deposits: ₹37.83 Cr | High Risk: 824 Customers (39.3%) | Balance at Risk: ₹19.67 Cr (52.0% of segment). High digital banking sensitivity.</a:t>
             </a:r>
           </a:p>
           <a:p>
@@ -9604,7 +9604,7 @@
               </a:defRPr>
             </a:pPr>
             <a:r>
-              <a:t>• Mass Retail Tier: 6,120 Customers (60.0% of base) | Total Deposits: ₹379.52 Cr | High Risk: 1,383 Customers | Balance at Risk: ₹67.15 Cr (17.7% of segment). Service friction &amp; fee dispute drivers.</a:t>
+              <a:t>• Mass Retail Tier: 7,236 Customers (70.9% of base) | Total Deposits: ₹28.12 Cr | High Risk: 1,115 Customers (15.4%) | Balance at Risk: ₹7.94 Cr (28.2% of segment). Service friction &amp; fee dispute drivers.</a:t>
             </a:r>
           </a:p>
           <a:p>
@@ -9617,7 +9617,7 @@
               </a:defRPr>
             </a:pPr>
             <a:r>
-              <a:t>• Strategic Takeaway [RECOMMENDED]: Retention efforts must not be democratic. Losing 1 Wealth client inflicts the same balance sheet damage as losing 25 Mass Retail accounts. Immediate executive focus on top 284 Wealth accounts.</a:t>
+              <a:t>• Strategic Takeaway [RECOMMENDED]: Retention efforts must not be democratic. Wealth accounts carry ₹39.73 Cr in at-risk balances (5x the entire Mass Retail exposure). Immediate frontline focus on top 463 at-risk Wealth accounts.</a:t>
             </a:r>
           </a:p>
         </p:txBody>

</xml_diff>